<commit_message>
fixed the plotting script
</commit_message>
<xml_diff>
--- a/docs/content/multivariate_statistics/multivariate_statistics_lecture.pptx
+++ b/docs/content/multivariate_statistics/multivariate_statistics_lecture.pptx
@@ -21774,7 +21774,7 @@
                 </a:solidFill>
                 <a:latin typeface="Courier"/>
               </a:rPr>
-              <a:t>## Model     1    47.72 0.10517 5.6414  0.005 **</a:t>
+              <a:t>## Model     1    47.72 0.10517 5.6414  0.003 **</a:t>
             </a:r>
             <a:br/>
             <a:r>
@@ -21934,7 +21934,7 @@
                 </a:solidFill>
                 <a:latin typeface="Courier"/>
               </a:rPr>
-              <a:t>## Model     1    26.24 0.06493 3.3333  0.022 *</a:t>
+              <a:t>## Model     1    26.24 0.06493 3.3333  0.024 *</a:t>
             </a:r>
             <a:br/>
             <a:r>
@@ -22605,7 +22605,7 @@
                 </a:solidFill>
                 <a:latin typeface="Courier"/>
               </a:rPr>
-              <a:t>## LEH 0.066 0.006 -    </a:t>
+              <a:t>## LEH 0.114 0.006 -    </a:t>
             </a:r>
             <a:br/>
             <a:r>
@@ -22615,7 +22615,7 @@
                 </a:solidFill>
                 <a:latin typeface="Courier"/>
               </a:rPr>
-              <a:t>## TJH 0.012 0.006 0.006</a:t>
+              <a:t>## TJH 0.012 0.006 0.012</a:t>
             </a:r>
             <a:br/>
             <a:r>

</xml_diff>

<commit_message>
fixed font and shading
</commit_message>
<xml_diff>
--- a/docs/content/multivariate_statistics/multivariate_statistics_lecture.pptx
+++ b/docs/content/multivariate_statistics/multivariate_statistics_lecture.pptx
@@ -21684,6 +21684,166 @@
                 </a:solidFill>
                 <a:latin typeface="Courier"/>
               </a:rPr>
+              <a:t>##          Df SumOfSqs      R2      F Pr(&gt;F)   </a:t>
+            </a:r>
+            <a:br/>
+            <a:r>
+              <a:rPr i="1">
+                <a:solidFill>
+                  <a:srgbClr val="5E5E5E"/>
+                </a:solidFill>
+                <a:latin typeface="Courier"/>
+              </a:rPr>
+              <a:t>## Model     1   32.602 0.10636 5.7128  0.003 **</a:t>
+            </a:r>
+            <a:br/>
+            <a:r>
+              <a:rPr i="1">
+                <a:solidFill>
+                  <a:srgbClr val="5E5E5E"/>
+                </a:solidFill>
+                <a:latin typeface="Courier"/>
+              </a:rPr>
+              <a:t>## Residual 48  273.930 0.89364                 </a:t>
+            </a:r>
+            <a:br/>
+            <a:r>
+              <a:rPr i="1">
+                <a:solidFill>
+                  <a:srgbClr val="5E5E5E"/>
+                </a:solidFill>
+                <a:latin typeface="Courier"/>
+              </a:rPr>
+              <a:t>## Total    49  306.532 1.00000                 </a:t>
+            </a:r>
+            <a:br/>
+            <a:r>
+              <a:rPr i="1">
+                <a:solidFill>
+                  <a:srgbClr val="5E5E5E"/>
+                </a:solidFill>
+                <a:latin typeface="Courier"/>
+              </a:rPr>
+              <a:t>## ---</a:t>
+            </a:r>
+            <a:br/>
+            <a:r>
+              <a:rPr i="1">
+                <a:solidFill>
+                  <a:srgbClr val="5E5E5E"/>
+                </a:solidFill>
+                <a:latin typeface="Courier"/>
+              </a:rPr>
+              <a:t>## Signif. codes:  0 '***' 0.001 '**' 0.01 '*' 0.05 '.' 0.1 ' ' 1</a:t>
+            </a:r>
+            <a:br/>
+            <a:r>
+              <a:rPr i="1">
+                <a:solidFill>
+                  <a:srgbClr val="5E5E5E"/>
+                </a:solidFill>
+                <a:latin typeface="Courier"/>
+              </a:rPr>
+              <a:t>## </a:t>
+            </a:r>
+            <a:br/>
+            <a:r>
+              <a:rPr i="1">
+                <a:solidFill>
+                  <a:srgbClr val="5E5E5E"/>
+                </a:solidFill>
+                <a:latin typeface="Courier"/>
+              </a:rPr>
+              <a:t>## $TJH_vs_LEH</a:t>
+            </a:r>
+            <a:br/>
+            <a:r>
+              <a:rPr i="1">
+                <a:solidFill>
+                  <a:srgbClr val="5E5E5E"/>
+                </a:solidFill>
+                <a:latin typeface="Courier"/>
+              </a:rPr>
+              <a:t>##          Df SumOfSqs      R2      F Pr(&gt;F)   </a:t>
+            </a:r>
+            <a:br/>
+            <a:r>
+              <a:rPr i="1">
+                <a:solidFill>
+                  <a:srgbClr val="5E5E5E"/>
+                </a:solidFill>
+                <a:latin typeface="Courier"/>
+              </a:rPr>
+              <a:t>## Model     1    47.72 0.10517 5.6414  0.003 **</a:t>
+            </a:r>
+            <a:br/>
+            <a:r>
+              <a:rPr i="1">
+                <a:solidFill>
+                  <a:srgbClr val="5E5E5E"/>
+                </a:solidFill>
+                <a:latin typeface="Courier"/>
+              </a:rPr>
+              <a:t>## Residual 48   406.06 0.89483                 </a:t>
+            </a:r>
+            <a:br/>
+            <a:r>
+              <a:rPr i="1">
+                <a:solidFill>
+                  <a:srgbClr val="5E5E5E"/>
+                </a:solidFill>
+                <a:latin typeface="Courier"/>
+              </a:rPr>
+              <a:t>## Total    49   453.78 1.00000                 </a:t>
+            </a:r>
+            <a:br/>
+            <a:r>
+              <a:rPr i="1">
+                <a:solidFill>
+                  <a:srgbClr val="5E5E5E"/>
+                </a:solidFill>
+                <a:latin typeface="Courier"/>
+              </a:rPr>
+              <a:t>## ---</a:t>
+            </a:r>
+            <a:br/>
+            <a:r>
+              <a:rPr i="1">
+                <a:solidFill>
+                  <a:srgbClr val="5E5E5E"/>
+                </a:solidFill>
+                <a:latin typeface="Courier"/>
+              </a:rPr>
+              <a:t>## Signif. codes:  0 '***' 0.001 '**' 0.01 '*' 0.05 '.' 0.1 ' ' 1</a:t>
+            </a:r>
+            <a:br/>
+            <a:r>
+              <a:rPr i="1">
+                <a:solidFill>
+                  <a:srgbClr val="5E5E5E"/>
+                </a:solidFill>
+                <a:latin typeface="Courier"/>
+              </a:rPr>
+              <a:t>## </a:t>
+            </a:r>
+            <a:br/>
+            <a:r>
+              <a:rPr i="1">
+                <a:solidFill>
+                  <a:srgbClr val="5E5E5E"/>
+                </a:solidFill>
+                <a:latin typeface="Courier"/>
+              </a:rPr>
+              <a:t>## $TJH_vs_HD</a:t>
+            </a:r>
+            <a:br/>
+            <a:r>
+              <a:rPr i="1">
+                <a:solidFill>
+                  <a:srgbClr val="5E5E5E"/>
+                </a:solidFill>
+                <a:latin typeface="Courier"/>
+              </a:rPr>
               <a:t>##          Df SumOfSqs      R2      F Pr(&gt;F)    </a:t>
             </a:r>
             <a:br/>
@@ -21694,7 +21854,7 @@
                 </a:solidFill>
                 <a:latin typeface="Courier"/>
               </a:rPr>
-              <a:t>## Model     1   32.602 0.10636 5.7128  0.001 ***</a:t>
+              <a:t>## Model     1   69.308 0.25135 11.751  0.001 ***</a:t>
             </a:r>
             <a:br/>
             <a:r>
@@ -21704,7 +21864,7 @@
                 </a:solidFill>
                 <a:latin typeface="Courier"/>
               </a:rPr>
-              <a:t>## Residual 48  273.930 0.89364                  </a:t>
+              <a:t>## Residual 35  206.432 0.74865                  </a:t>
             </a:r>
             <a:br/>
             <a:r>
@@ -21714,7 +21874,7 @@
                 </a:solidFill>
                 <a:latin typeface="Courier"/>
               </a:rPr>
-              <a:t>## Total    49  306.532 1.00000                  </a:t>
+              <a:t>## Total    36  275.740 1.00000                  </a:t>
             </a:r>
             <a:br/>
             <a:r>
@@ -21754,7 +21914,7 @@
                 </a:solidFill>
                 <a:latin typeface="Courier"/>
               </a:rPr>
-              <a:t>## $TJH_vs_LEH</a:t>
+              <a:t>## $DG_vs_LEH</a:t>
             </a:r>
             <a:br/>
             <a:r>
@@ -21764,7 +21924,7 @@
                 </a:solidFill>
                 <a:latin typeface="Courier"/>
               </a:rPr>
-              <a:t>##          Df SumOfSqs      R2      F Pr(&gt;F)   </a:t>
+              <a:t>##          Df SumOfSqs      R2      F Pr(&gt;F)  </a:t>
             </a:r>
             <a:br/>
             <a:r>
@@ -21774,167 +21934,7 @@
                 </a:solidFill>
                 <a:latin typeface="Courier"/>
               </a:rPr>
-              <a:t>## Model     1    47.72 0.10517 5.6414  0.003 **</a:t>
-            </a:r>
-            <a:br/>
-            <a:r>
-              <a:rPr i="1">
-                <a:solidFill>
-                  <a:srgbClr val="5E5E5E"/>
-                </a:solidFill>
-                <a:latin typeface="Courier"/>
-              </a:rPr>
-              <a:t>## Residual 48   406.06 0.89483                 </a:t>
-            </a:r>
-            <a:br/>
-            <a:r>
-              <a:rPr i="1">
-                <a:solidFill>
-                  <a:srgbClr val="5E5E5E"/>
-                </a:solidFill>
-                <a:latin typeface="Courier"/>
-              </a:rPr>
-              <a:t>## Total    49   453.78 1.00000                 </a:t>
-            </a:r>
-            <a:br/>
-            <a:r>
-              <a:rPr i="1">
-                <a:solidFill>
-                  <a:srgbClr val="5E5E5E"/>
-                </a:solidFill>
-                <a:latin typeface="Courier"/>
-              </a:rPr>
-              <a:t>## ---</a:t>
-            </a:r>
-            <a:br/>
-            <a:r>
-              <a:rPr i="1">
-                <a:solidFill>
-                  <a:srgbClr val="5E5E5E"/>
-                </a:solidFill>
-                <a:latin typeface="Courier"/>
-              </a:rPr>
-              <a:t>## Signif. codes:  0 '***' 0.001 '**' 0.01 '*' 0.05 '.' 0.1 ' ' 1</a:t>
-            </a:r>
-            <a:br/>
-            <a:r>
-              <a:rPr i="1">
-                <a:solidFill>
-                  <a:srgbClr val="5E5E5E"/>
-                </a:solidFill>
-                <a:latin typeface="Courier"/>
-              </a:rPr>
-              <a:t>## </a:t>
-            </a:r>
-            <a:br/>
-            <a:r>
-              <a:rPr i="1">
-                <a:solidFill>
-                  <a:srgbClr val="5E5E5E"/>
-                </a:solidFill>
-                <a:latin typeface="Courier"/>
-              </a:rPr>
-              <a:t>## $TJH_vs_HD</a:t>
-            </a:r>
-            <a:br/>
-            <a:r>
-              <a:rPr i="1">
-                <a:solidFill>
-                  <a:srgbClr val="5E5E5E"/>
-                </a:solidFill>
-                <a:latin typeface="Courier"/>
-              </a:rPr>
-              <a:t>##          Df SumOfSqs      R2      F Pr(&gt;F)    </a:t>
-            </a:r>
-            <a:br/>
-            <a:r>
-              <a:rPr i="1">
-                <a:solidFill>
-                  <a:srgbClr val="5E5E5E"/>
-                </a:solidFill>
-                <a:latin typeface="Courier"/>
-              </a:rPr>
-              <a:t>## Model     1   69.308 0.25135 11.751  0.001 ***</a:t>
-            </a:r>
-            <a:br/>
-            <a:r>
-              <a:rPr i="1">
-                <a:solidFill>
-                  <a:srgbClr val="5E5E5E"/>
-                </a:solidFill>
-                <a:latin typeface="Courier"/>
-              </a:rPr>
-              <a:t>## Residual 35  206.432 0.74865                  </a:t>
-            </a:r>
-            <a:br/>
-            <a:r>
-              <a:rPr i="1">
-                <a:solidFill>
-                  <a:srgbClr val="5E5E5E"/>
-                </a:solidFill>
-                <a:latin typeface="Courier"/>
-              </a:rPr>
-              <a:t>## Total    36  275.740 1.00000                  </a:t>
-            </a:r>
-            <a:br/>
-            <a:r>
-              <a:rPr i="1">
-                <a:solidFill>
-                  <a:srgbClr val="5E5E5E"/>
-                </a:solidFill>
-                <a:latin typeface="Courier"/>
-              </a:rPr>
-              <a:t>## ---</a:t>
-            </a:r>
-            <a:br/>
-            <a:r>
-              <a:rPr i="1">
-                <a:solidFill>
-                  <a:srgbClr val="5E5E5E"/>
-                </a:solidFill>
-                <a:latin typeface="Courier"/>
-              </a:rPr>
-              <a:t>## Signif. codes:  0 '***' 0.001 '**' 0.01 '*' 0.05 '.' 0.1 ' ' 1</a:t>
-            </a:r>
-            <a:br/>
-            <a:r>
-              <a:rPr i="1">
-                <a:solidFill>
-                  <a:srgbClr val="5E5E5E"/>
-                </a:solidFill>
-                <a:latin typeface="Courier"/>
-              </a:rPr>
-              <a:t>## </a:t>
-            </a:r>
-            <a:br/>
-            <a:r>
-              <a:rPr i="1">
-                <a:solidFill>
-                  <a:srgbClr val="5E5E5E"/>
-                </a:solidFill>
-                <a:latin typeface="Courier"/>
-              </a:rPr>
-              <a:t>## $DG_vs_LEH</a:t>
-            </a:r>
-            <a:br/>
-            <a:r>
-              <a:rPr i="1">
-                <a:solidFill>
-                  <a:srgbClr val="5E5E5E"/>
-                </a:solidFill>
-                <a:latin typeface="Courier"/>
-              </a:rPr>
-              <a:t>##          Df SumOfSqs      R2      F Pr(&gt;F)  </a:t>
-            </a:r>
-            <a:br/>
-            <a:r>
-              <a:rPr i="1">
-                <a:solidFill>
-                  <a:srgbClr val="5E5E5E"/>
-                </a:solidFill>
-                <a:latin typeface="Courier"/>
-              </a:rPr>
-              <a:t>## Model     1    26.24 0.06493 3.3333  0.024 *</a:t>
+              <a:t>## Model     1    26.24 0.06493 3.3333  0.016 *</a:t>
             </a:r>
             <a:br/>
             <a:r>
@@ -22615,7 +22615,7 @@
                 </a:solidFill>
                 <a:latin typeface="Courier"/>
               </a:rPr>
-              <a:t>## TJH 0.012 0.006 0.012</a:t>
+              <a:t>## TJH 0.006 0.006 0.012</a:t>
             </a:r>
             <a:br/>
             <a:r>

</xml_diff>

<commit_message>
fixed z and t tables
</commit_message>
<xml_diff>
--- a/docs/content/multivariate_statistics/multivariate_statistics_lecture.pptx
+++ b/docs/content/multivariate_statistics/multivariate_statistics_lecture.pptx
@@ -21684,6 +21684,166 @@
                 </a:solidFill>
                 <a:latin typeface="Courier"/>
               </a:rPr>
+              <a:t>##          Df SumOfSqs      R2      F Pr(&gt;F)   </a:t>
+            </a:r>
+            <a:br/>
+            <a:r>
+              <a:rPr i="1">
+                <a:solidFill>
+                  <a:srgbClr val="5E5E5E"/>
+                </a:solidFill>
+                <a:latin typeface="Courier"/>
+              </a:rPr>
+              <a:t>## Model     1   32.602 0.10636 5.7128  0.003 **</a:t>
+            </a:r>
+            <a:br/>
+            <a:r>
+              <a:rPr i="1">
+                <a:solidFill>
+                  <a:srgbClr val="5E5E5E"/>
+                </a:solidFill>
+                <a:latin typeface="Courier"/>
+              </a:rPr>
+              <a:t>## Residual 48  273.930 0.89364                 </a:t>
+            </a:r>
+            <a:br/>
+            <a:r>
+              <a:rPr i="1">
+                <a:solidFill>
+                  <a:srgbClr val="5E5E5E"/>
+                </a:solidFill>
+                <a:latin typeface="Courier"/>
+              </a:rPr>
+              <a:t>## Total    49  306.532 1.00000                 </a:t>
+            </a:r>
+            <a:br/>
+            <a:r>
+              <a:rPr i="1">
+                <a:solidFill>
+                  <a:srgbClr val="5E5E5E"/>
+                </a:solidFill>
+                <a:latin typeface="Courier"/>
+              </a:rPr>
+              <a:t>## ---</a:t>
+            </a:r>
+            <a:br/>
+            <a:r>
+              <a:rPr i="1">
+                <a:solidFill>
+                  <a:srgbClr val="5E5E5E"/>
+                </a:solidFill>
+                <a:latin typeface="Courier"/>
+              </a:rPr>
+              <a:t>## Signif. codes:  0 '***' 0.001 '**' 0.01 '*' 0.05 '.' 0.1 ' ' 1</a:t>
+            </a:r>
+            <a:br/>
+            <a:r>
+              <a:rPr i="1">
+                <a:solidFill>
+                  <a:srgbClr val="5E5E5E"/>
+                </a:solidFill>
+                <a:latin typeface="Courier"/>
+              </a:rPr>
+              <a:t>## </a:t>
+            </a:r>
+            <a:br/>
+            <a:r>
+              <a:rPr i="1">
+                <a:solidFill>
+                  <a:srgbClr val="5E5E5E"/>
+                </a:solidFill>
+                <a:latin typeface="Courier"/>
+              </a:rPr>
+              <a:t>## $TJH_vs_LEH</a:t>
+            </a:r>
+            <a:br/>
+            <a:r>
+              <a:rPr i="1">
+                <a:solidFill>
+                  <a:srgbClr val="5E5E5E"/>
+                </a:solidFill>
+                <a:latin typeface="Courier"/>
+              </a:rPr>
+              <a:t>##          Df SumOfSqs      R2      F Pr(&gt;F)   </a:t>
+            </a:r>
+            <a:br/>
+            <a:r>
+              <a:rPr i="1">
+                <a:solidFill>
+                  <a:srgbClr val="5E5E5E"/>
+                </a:solidFill>
+                <a:latin typeface="Courier"/>
+              </a:rPr>
+              <a:t>## Model     1    47.72 0.10517 5.6414  0.002 **</a:t>
+            </a:r>
+            <a:br/>
+            <a:r>
+              <a:rPr i="1">
+                <a:solidFill>
+                  <a:srgbClr val="5E5E5E"/>
+                </a:solidFill>
+                <a:latin typeface="Courier"/>
+              </a:rPr>
+              <a:t>## Residual 48   406.06 0.89483                 </a:t>
+            </a:r>
+            <a:br/>
+            <a:r>
+              <a:rPr i="1">
+                <a:solidFill>
+                  <a:srgbClr val="5E5E5E"/>
+                </a:solidFill>
+                <a:latin typeface="Courier"/>
+              </a:rPr>
+              <a:t>## Total    49   453.78 1.00000                 </a:t>
+            </a:r>
+            <a:br/>
+            <a:r>
+              <a:rPr i="1">
+                <a:solidFill>
+                  <a:srgbClr val="5E5E5E"/>
+                </a:solidFill>
+                <a:latin typeface="Courier"/>
+              </a:rPr>
+              <a:t>## ---</a:t>
+            </a:r>
+            <a:br/>
+            <a:r>
+              <a:rPr i="1">
+                <a:solidFill>
+                  <a:srgbClr val="5E5E5E"/>
+                </a:solidFill>
+                <a:latin typeface="Courier"/>
+              </a:rPr>
+              <a:t>## Signif. codes:  0 '***' 0.001 '**' 0.01 '*' 0.05 '.' 0.1 ' ' 1</a:t>
+            </a:r>
+            <a:br/>
+            <a:r>
+              <a:rPr i="1">
+                <a:solidFill>
+                  <a:srgbClr val="5E5E5E"/>
+                </a:solidFill>
+                <a:latin typeface="Courier"/>
+              </a:rPr>
+              <a:t>## </a:t>
+            </a:r>
+            <a:br/>
+            <a:r>
+              <a:rPr i="1">
+                <a:solidFill>
+                  <a:srgbClr val="5E5E5E"/>
+                </a:solidFill>
+                <a:latin typeface="Courier"/>
+              </a:rPr>
+              <a:t>## $TJH_vs_HD</a:t>
+            </a:r>
+            <a:br/>
+            <a:r>
+              <a:rPr i="1">
+                <a:solidFill>
+                  <a:srgbClr val="5E5E5E"/>
+                </a:solidFill>
+                <a:latin typeface="Courier"/>
+              </a:rPr>
               <a:t>##          Df SumOfSqs      R2      F Pr(&gt;F)    </a:t>
             </a:r>
             <a:br/>
@@ -21694,7 +21854,7 @@
                 </a:solidFill>
                 <a:latin typeface="Courier"/>
               </a:rPr>
-              <a:t>## Model     1   32.602 0.10636 5.7128  0.001 ***</a:t>
+              <a:t>## Model     1   69.308 0.25135 11.751  0.001 ***</a:t>
             </a:r>
             <a:br/>
             <a:r>
@@ -21704,7 +21864,7 @@
                 </a:solidFill>
                 <a:latin typeface="Courier"/>
               </a:rPr>
-              <a:t>## Residual 48  273.930 0.89364                  </a:t>
+              <a:t>## Residual 35  206.432 0.74865                  </a:t>
             </a:r>
             <a:br/>
             <a:r>
@@ -21714,7 +21874,7 @@
                 </a:solidFill>
                 <a:latin typeface="Courier"/>
               </a:rPr>
-              <a:t>## Total    49  306.532 1.00000                  </a:t>
+              <a:t>## Total    36  275.740 1.00000                  </a:t>
             </a:r>
             <a:br/>
             <a:r>
@@ -21754,7 +21914,7 @@
                 </a:solidFill>
                 <a:latin typeface="Courier"/>
               </a:rPr>
-              <a:t>## $TJH_vs_LEH</a:t>
+              <a:t>## $DG_vs_LEH</a:t>
             </a:r>
             <a:br/>
             <a:r>
@@ -21764,7 +21924,7 @@
                 </a:solidFill>
                 <a:latin typeface="Courier"/>
               </a:rPr>
-              <a:t>##          Df SumOfSqs      R2      F Pr(&gt;F)    </a:t>
+              <a:t>##          Df SumOfSqs      R2      F Pr(&gt;F)  </a:t>
             </a:r>
             <a:br/>
             <a:r>
@@ -21774,167 +21934,7 @@
                 </a:solidFill>
                 <a:latin typeface="Courier"/>
               </a:rPr>
-              <a:t>## Model     1    47.72 0.10517 5.6414  0.001 ***</a:t>
-            </a:r>
-            <a:br/>
-            <a:r>
-              <a:rPr i="1">
-                <a:solidFill>
-                  <a:srgbClr val="5E5E5E"/>
-                </a:solidFill>
-                <a:latin typeface="Courier"/>
-              </a:rPr>
-              <a:t>## Residual 48   406.06 0.89483                  </a:t>
-            </a:r>
-            <a:br/>
-            <a:r>
-              <a:rPr i="1">
-                <a:solidFill>
-                  <a:srgbClr val="5E5E5E"/>
-                </a:solidFill>
-                <a:latin typeface="Courier"/>
-              </a:rPr>
-              <a:t>## Total    49   453.78 1.00000                  </a:t>
-            </a:r>
-            <a:br/>
-            <a:r>
-              <a:rPr i="1">
-                <a:solidFill>
-                  <a:srgbClr val="5E5E5E"/>
-                </a:solidFill>
-                <a:latin typeface="Courier"/>
-              </a:rPr>
-              <a:t>## ---</a:t>
-            </a:r>
-            <a:br/>
-            <a:r>
-              <a:rPr i="1">
-                <a:solidFill>
-                  <a:srgbClr val="5E5E5E"/>
-                </a:solidFill>
-                <a:latin typeface="Courier"/>
-              </a:rPr>
-              <a:t>## Signif. codes:  0 '***' 0.001 '**' 0.01 '*' 0.05 '.' 0.1 ' ' 1</a:t>
-            </a:r>
-            <a:br/>
-            <a:r>
-              <a:rPr i="1">
-                <a:solidFill>
-                  <a:srgbClr val="5E5E5E"/>
-                </a:solidFill>
-                <a:latin typeface="Courier"/>
-              </a:rPr>
-              <a:t>## </a:t>
-            </a:r>
-            <a:br/>
-            <a:r>
-              <a:rPr i="1">
-                <a:solidFill>
-                  <a:srgbClr val="5E5E5E"/>
-                </a:solidFill>
-                <a:latin typeface="Courier"/>
-              </a:rPr>
-              <a:t>## $TJH_vs_HD</a:t>
-            </a:r>
-            <a:br/>
-            <a:r>
-              <a:rPr i="1">
-                <a:solidFill>
-                  <a:srgbClr val="5E5E5E"/>
-                </a:solidFill>
-                <a:latin typeface="Courier"/>
-              </a:rPr>
-              <a:t>##          Df SumOfSqs      R2      F Pr(&gt;F)    </a:t>
-            </a:r>
-            <a:br/>
-            <a:r>
-              <a:rPr i="1">
-                <a:solidFill>
-                  <a:srgbClr val="5E5E5E"/>
-                </a:solidFill>
-                <a:latin typeface="Courier"/>
-              </a:rPr>
-              <a:t>## Model     1   69.308 0.25135 11.751  0.001 ***</a:t>
-            </a:r>
-            <a:br/>
-            <a:r>
-              <a:rPr i="1">
-                <a:solidFill>
-                  <a:srgbClr val="5E5E5E"/>
-                </a:solidFill>
-                <a:latin typeface="Courier"/>
-              </a:rPr>
-              <a:t>## Residual 35  206.432 0.74865                  </a:t>
-            </a:r>
-            <a:br/>
-            <a:r>
-              <a:rPr i="1">
-                <a:solidFill>
-                  <a:srgbClr val="5E5E5E"/>
-                </a:solidFill>
-                <a:latin typeface="Courier"/>
-              </a:rPr>
-              <a:t>## Total    36  275.740 1.00000                  </a:t>
-            </a:r>
-            <a:br/>
-            <a:r>
-              <a:rPr i="1">
-                <a:solidFill>
-                  <a:srgbClr val="5E5E5E"/>
-                </a:solidFill>
-                <a:latin typeface="Courier"/>
-              </a:rPr>
-              <a:t>## ---</a:t>
-            </a:r>
-            <a:br/>
-            <a:r>
-              <a:rPr i="1">
-                <a:solidFill>
-                  <a:srgbClr val="5E5E5E"/>
-                </a:solidFill>
-                <a:latin typeface="Courier"/>
-              </a:rPr>
-              <a:t>## Signif. codes:  0 '***' 0.001 '**' 0.01 '*' 0.05 '.' 0.1 ' ' 1</a:t>
-            </a:r>
-            <a:br/>
-            <a:r>
-              <a:rPr i="1">
-                <a:solidFill>
-                  <a:srgbClr val="5E5E5E"/>
-                </a:solidFill>
-                <a:latin typeface="Courier"/>
-              </a:rPr>
-              <a:t>## </a:t>
-            </a:r>
-            <a:br/>
-            <a:r>
-              <a:rPr i="1">
-                <a:solidFill>
-                  <a:srgbClr val="5E5E5E"/>
-                </a:solidFill>
-                <a:latin typeface="Courier"/>
-              </a:rPr>
-              <a:t>## $DG_vs_LEH</a:t>
-            </a:r>
-            <a:br/>
-            <a:r>
-              <a:rPr i="1">
-                <a:solidFill>
-                  <a:srgbClr val="5E5E5E"/>
-                </a:solidFill>
-                <a:latin typeface="Courier"/>
-              </a:rPr>
-              <a:t>##          Df SumOfSqs      R2      F Pr(&gt;F)  </a:t>
-            </a:r>
-            <a:br/>
-            <a:r>
-              <a:rPr i="1">
-                <a:solidFill>
-                  <a:srgbClr val="5E5E5E"/>
-                </a:solidFill>
-                <a:latin typeface="Courier"/>
-              </a:rPr>
-              <a:t>## Model     1    26.24 0.06493 3.3333  0.017 *</a:t>
+              <a:t>## Model     1    26.24 0.06493 3.3333  0.013 *</a:t>
             </a:r>
             <a:br/>
             <a:r>
@@ -22605,7 +22605,7 @@
                 </a:solidFill>
                 <a:latin typeface="Courier"/>
               </a:rPr>
-              <a:t>## LEH 0.114 0.006 -    </a:t>
+              <a:t>## LEH 0.132 0.006 -    </a:t>
             </a:r>
             <a:br/>
             <a:r>
@@ -22615,7 +22615,7 @@
                 </a:solidFill>
                 <a:latin typeface="Courier"/>
               </a:rPr>
-              <a:t>## TJH 0.012 0.006 0.006</a:t>
+              <a:t>## TJH 0.012 0.006 0.024</a:t>
             </a:r>
             <a:br/>
             <a:r>

</xml_diff>

<commit_message>
fixed non parametric t tests and cleaned skeletons and such
</commit_message>
<xml_diff>
--- a/docs/content/multivariate_statistics/multivariate_statistics_lecture.pptx
+++ b/docs/content/multivariate_statistics/multivariate_statistics_lecture.pptx
@@ -21774,7 +21774,7 @@
                 </a:solidFill>
                 <a:latin typeface="Courier"/>
               </a:rPr>
-              <a:t>## Model     1    47.72 0.10517 5.6414  0.002 **</a:t>
+              <a:t>## Model     1    47.72 0.10517 5.6414  0.003 **</a:t>
             </a:r>
             <a:br/>
             <a:r>
@@ -21934,7 +21934,7 @@
                 </a:solidFill>
                 <a:latin typeface="Courier"/>
               </a:rPr>
-              <a:t>## Model     1    26.24 0.06493 3.3333  0.018 *</a:t>
+              <a:t>## Model     1    26.24 0.06493 3.3333  0.019 *</a:t>
             </a:r>
             <a:br/>
             <a:r>

</xml_diff>

<commit_message>
fixed desing to be more interacive
</commit_message>
<xml_diff>
--- a/docs/content/multivariate_statistics/multivariate_statistics_lecture.pptx
+++ b/docs/content/multivariate_statistics/multivariate_statistics_lecture.pptx
@@ -21684,6 +21684,166 @@
                 </a:solidFill>
                 <a:latin typeface="Courier"/>
               </a:rPr>
+              <a:t>##          Df SumOfSqs      R2      F Pr(&gt;F)   </a:t>
+            </a:r>
+            <a:br/>
+            <a:r>
+              <a:rPr i="1">
+                <a:solidFill>
+                  <a:srgbClr val="5E5E5E"/>
+                </a:solidFill>
+                <a:latin typeface="Courier"/>
+              </a:rPr>
+              <a:t>## Model     1   32.602 0.10636 5.7128  0.002 **</a:t>
+            </a:r>
+            <a:br/>
+            <a:r>
+              <a:rPr i="1">
+                <a:solidFill>
+                  <a:srgbClr val="5E5E5E"/>
+                </a:solidFill>
+                <a:latin typeface="Courier"/>
+              </a:rPr>
+              <a:t>## Residual 48  273.930 0.89364                 </a:t>
+            </a:r>
+            <a:br/>
+            <a:r>
+              <a:rPr i="1">
+                <a:solidFill>
+                  <a:srgbClr val="5E5E5E"/>
+                </a:solidFill>
+                <a:latin typeface="Courier"/>
+              </a:rPr>
+              <a:t>## Total    49  306.532 1.00000                 </a:t>
+            </a:r>
+            <a:br/>
+            <a:r>
+              <a:rPr i="1">
+                <a:solidFill>
+                  <a:srgbClr val="5E5E5E"/>
+                </a:solidFill>
+                <a:latin typeface="Courier"/>
+              </a:rPr>
+              <a:t>## ---</a:t>
+            </a:r>
+            <a:br/>
+            <a:r>
+              <a:rPr i="1">
+                <a:solidFill>
+                  <a:srgbClr val="5E5E5E"/>
+                </a:solidFill>
+                <a:latin typeface="Courier"/>
+              </a:rPr>
+              <a:t>## Signif. codes:  0 '***' 0.001 '**' 0.01 '*' 0.05 '.' 0.1 ' ' 1</a:t>
+            </a:r>
+            <a:br/>
+            <a:r>
+              <a:rPr i="1">
+                <a:solidFill>
+                  <a:srgbClr val="5E5E5E"/>
+                </a:solidFill>
+                <a:latin typeface="Courier"/>
+              </a:rPr>
+              <a:t>## </a:t>
+            </a:r>
+            <a:br/>
+            <a:r>
+              <a:rPr i="1">
+                <a:solidFill>
+                  <a:srgbClr val="5E5E5E"/>
+                </a:solidFill>
+                <a:latin typeface="Courier"/>
+              </a:rPr>
+              <a:t>## $TJH_vs_LEH</a:t>
+            </a:r>
+            <a:br/>
+            <a:r>
+              <a:rPr i="1">
+                <a:solidFill>
+                  <a:srgbClr val="5E5E5E"/>
+                </a:solidFill>
+                <a:latin typeface="Courier"/>
+              </a:rPr>
+              <a:t>##          Df SumOfSqs      R2      F Pr(&gt;F)   </a:t>
+            </a:r>
+            <a:br/>
+            <a:r>
+              <a:rPr i="1">
+                <a:solidFill>
+                  <a:srgbClr val="5E5E5E"/>
+                </a:solidFill>
+                <a:latin typeface="Courier"/>
+              </a:rPr>
+              <a:t>## Model     1    47.72 0.10517 5.6414  0.006 **</a:t>
+            </a:r>
+            <a:br/>
+            <a:r>
+              <a:rPr i="1">
+                <a:solidFill>
+                  <a:srgbClr val="5E5E5E"/>
+                </a:solidFill>
+                <a:latin typeface="Courier"/>
+              </a:rPr>
+              <a:t>## Residual 48   406.06 0.89483                 </a:t>
+            </a:r>
+            <a:br/>
+            <a:r>
+              <a:rPr i="1">
+                <a:solidFill>
+                  <a:srgbClr val="5E5E5E"/>
+                </a:solidFill>
+                <a:latin typeface="Courier"/>
+              </a:rPr>
+              <a:t>## Total    49   453.78 1.00000                 </a:t>
+            </a:r>
+            <a:br/>
+            <a:r>
+              <a:rPr i="1">
+                <a:solidFill>
+                  <a:srgbClr val="5E5E5E"/>
+                </a:solidFill>
+                <a:latin typeface="Courier"/>
+              </a:rPr>
+              <a:t>## ---</a:t>
+            </a:r>
+            <a:br/>
+            <a:r>
+              <a:rPr i="1">
+                <a:solidFill>
+                  <a:srgbClr val="5E5E5E"/>
+                </a:solidFill>
+                <a:latin typeface="Courier"/>
+              </a:rPr>
+              <a:t>## Signif. codes:  0 '***' 0.001 '**' 0.01 '*' 0.05 '.' 0.1 ' ' 1</a:t>
+            </a:r>
+            <a:br/>
+            <a:r>
+              <a:rPr i="1">
+                <a:solidFill>
+                  <a:srgbClr val="5E5E5E"/>
+                </a:solidFill>
+                <a:latin typeface="Courier"/>
+              </a:rPr>
+              <a:t>## </a:t>
+            </a:r>
+            <a:br/>
+            <a:r>
+              <a:rPr i="1">
+                <a:solidFill>
+                  <a:srgbClr val="5E5E5E"/>
+                </a:solidFill>
+                <a:latin typeface="Courier"/>
+              </a:rPr>
+              <a:t>## $TJH_vs_HD</a:t>
+            </a:r>
+            <a:br/>
+            <a:r>
+              <a:rPr i="1">
+                <a:solidFill>
+                  <a:srgbClr val="5E5E5E"/>
+                </a:solidFill>
+                <a:latin typeface="Courier"/>
+              </a:rPr>
               <a:t>##          Df SumOfSqs      R2      F Pr(&gt;F)    </a:t>
             </a:r>
             <a:br/>
@@ -21694,7 +21854,7 @@
                 </a:solidFill>
                 <a:latin typeface="Courier"/>
               </a:rPr>
-              <a:t>## Model     1   32.602 0.10636 5.7128  0.001 ***</a:t>
+              <a:t>## Model     1   69.308 0.25135 11.751  0.001 ***</a:t>
             </a:r>
             <a:br/>
             <a:r>
@@ -21704,7 +21864,7 @@
                 </a:solidFill>
                 <a:latin typeface="Courier"/>
               </a:rPr>
-              <a:t>## Residual 48  273.930 0.89364                  </a:t>
+              <a:t>## Residual 35  206.432 0.74865                  </a:t>
             </a:r>
             <a:br/>
             <a:r>
@@ -21714,7 +21874,7 @@
                 </a:solidFill>
                 <a:latin typeface="Courier"/>
               </a:rPr>
-              <a:t>## Total    49  306.532 1.00000                  </a:t>
+              <a:t>## Total    36  275.740 1.00000                  </a:t>
             </a:r>
             <a:br/>
             <a:r>
@@ -21754,7 +21914,7 @@
                 </a:solidFill>
                 <a:latin typeface="Courier"/>
               </a:rPr>
-              <a:t>## $TJH_vs_LEH</a:t>
+              <a:t>## $DG_vs_LEH</a:t>
             </a:r>
             <a:br/>
             <a:r>
@@ -21764,7 +21924,7 @@
                 </a:solidFill>
                 <a:latin typeface="Courier"/>
               </a:rPr>
-              <a:t>##          Df SumOfSqs      R2      F Pr(&gt;F)   </a:t>
+              <a:t>##          Df SumOfSqs      R2      F Pr(&gt;F)  </a:t>
             </a:r>
             <a:br/>
             <a:r>
@@ -21774,167 +21934,7 @@
                 </a:solidFill>
                 <a:latin typeface="Courier"/>
               </a:rPr>
-              <a:t>## Model     1    47.72 0.10517 5.6414  0.002 **</a:t>
-            </a:r>
-            <a:br/>
-            <a:r>
-              <a:rPr i="1">
-                <a:solidFill>
-                  <a:srgbClr val="5E5E5E"/>
-                </a:solidFill>
-                <a:latin typeface="Courier"/>
-              </a:rPr>
-              <a:t>## Residual 48   406.06 0.89483                 </a:t>
-            </a:r>
-            <a:br/>
-            <a:r>
-              <a:rPr i="1">
-                <a:solidFill>
-                  <a:srgbClr val="5E5E5E"/>
-                </a:solidFill>
-                <a:latin typeface="Courier"/>
-              </a:rPr>
-              <a:t>## Total    49   453.78 1.00000                 </a:t>
-            </a:r>
-            <a:br/>
-            <a:r>
-              <a:rPr i="1">
-                <a:solidFill>
-                  <a:srgbClr val="5E5E5E"/>
-                </a:solidFill>
-                <a:latin typeface="Courier"/>
-              </a:rPr>
-              <a:t>## ---</a:t>
-            </a:r>
-            <a:br/>
-            <a:r>
-              <a:rPr i="1">
-                <a:solidFill>
-                  <a:srgbClr val="5E5E5E"/>
-                </a:solidFill>
-                <a:latin typeface="Courier"/>
-              </a:rPr>
-              <a:t>## Signif. codes:  0 '***' 0.001 '**' 0.01 '*' 0.05 '.' 0.1 ' ' 1</a:t>
-            </a:r>
-            <a:br/>
-            <a:r>
-              <a:rPr i="1">
-                <a:solidFill>
-                  <a:srgbClr val="5E5E5E"/>
-                </a:solidFill>
-                <a:latin typeface="Courier"/>
-              </a:rPr>
-              <a:t>## </a:t>
-            </a:r>
-            <a:br/>
-            <a:r>
-              <a:rPr i="1">
-                <a:solidFill>
-                  <a:srgbClr val="5E5E5E"/>
-                </a:solidFill>
-                <a:latin typeface="Courier"/>
-              </a:rPr>
-              <a:t>## $TJH_vs_HD</a:t>
-            </a:r>
-            <a:br/>
-            <a:r>
-              <a:rPr i="1">
-                <a:solidFill>
-                  <a:srgbClr val="5E5E5E"/>
-                </a:solidFill>
-                <a:latin typeface="Courier"/>
-              </a:rPr>
-              <a:t>##          Df SumOfSqs      R2      F Pr(&gt;F)    </a:t>
-            </a:r>
-            <a:br/>
-            <a:r>
-              <a:rPr i="1">
-                <a:solidFill>
-                  <a:srgbClr val="5E5E5E"/>
-                </a:solidFill>
-                <a:latin typeface="Courier"/>
-              </a:rPr>
-              <a:t>## Model     1   69.308 0.25135 11.751  0.001 ***</a:t>
-            </a:r>
-            <a:br/>
-            <a:r>
-              <a:rPr i="1">
-                <a:solidFill>
-                  <a:srgbClr val="5E5E5E"/>
-                </a:solidFill>
-                <a:latin typeface="Courier"/>
-              </a:rPr>
-              <a:t>## Residual 35  206.432 0.74865                  </a:t>
-            </a:r>
-            <a:br/>
-            <a:r>
-              <a:rPr i="1">
-                <a:solidFill>
-                  <a:srgbClr val="5E5E5E"/>
-                </a:solidFill>
-                <a:latin typeface="Courier"/>
-              </a:rPr>
-              <a:t>## Total    36  275.740 1.00000                  </a:t>
-            </a:r>
-            <a:br/>
-            <a:r>
-              <a:rPr i="1">
-                <a:solidFill>
-                  <a:srgbClr val="5E5E5E"/>
-                </a:solidFill>
-                <a:latin typeface="Courier"/>
-              </a:rPr>
-              <a:t>## ---</a:t>
-            </a:r>
-            <a:br/>
-            <a:r>
-              <a:rPr i="1">
-                <a:solidFill>
-                  <a:srgbClr val="5E5E5E"/>
-                </a:solidFill>
-                <a:latin typeface="Courier"/>
-              </a:rPr>
-              <a:t>## Signif. codes:  0 '***' 0.001 '**' 0.01 '*' 0.05 '.' 0.1 ' ' 1</a:t>
-            </a:r>
-            <a:br/>
-            <a:r>
-              <a:rPr i="1">
-                <a:solidFill>
-                  <a:srgbClr val="5E5E5E"/>
-                </a:solidFill>
-                <a:latin typeface="Courier"/>
-              </a:rPr>
-              <a:t>## </a:t>
-            </a:r>
-            <a:br/>
-            <a:r>
-              <a:rPr i="1">
-                <a:solidFill>
-                  <a:srgbClr val="5E5E5E"/>
-                </a:solidFill>
-                <a:latin typeface="Courier"/>
-              </a:rPr>
-              <a:t>## $DG_vs_LEH</a:t>
-            </a:r>
-            <a:br/>
-            <a:r>
-              <a:rPr i="1">
-                <a:solidFill>
-                  <a:srgbClr val="5E5E5E"/>
-                </a:solidFill>
-                <a:latin typeface="Courier"/>
-              </a:rPr>
-              <a:t>##          Df SumOfSqs      R2      F Pr(&gt;F)  </a:t>
-            </a:r>
-            <a:br/>
-            <a:r>
-              <a:rPr i="1">
-                <a:solidFill>
-                  <a:srgbClr val="5E5E5E"/>
-                </a:solidFill>
-                <a:latin typeface="Courier"/>
-              </a:rPr>
-              <a:t>## Model     1    26.24 0.06493 3.3333  0.014 *</a:t>
+              <a:t>## Model     1    26.24 0.06493 3.3333  0.027 *</a:t>
             </a:r>
             <a:br/>
             <a:r>
@@ -22605,7 +22605,7 @@
                 </a:solidFill>
                 <a:latin typeface="Courier"/>
               </a:rPr>
-              <a:t>## LEH 0.150 0.006 -    </a:t>
+              <a:t>## LEH 0.096 0.006 -    </a:t>
             </a:r>
             <a:br/>
             <a:r>
@@ -22615,7 +22615,7 @@
                 </a:solidFill>
                 <a:latin typeface="Courier"/>
               </a:rPr>
-              <a:t>## TJH 0.018 0.006 0.030</a:t>
+              <a:t>## TJH 0.006 0.006 0.018</a:t>
             </a:r>
             <a:br/>
             <a:r>

</xml_diff>

<commit_message>
fixed the sampling design lecture and its GREAT now... will not do activity
</commit_message>
<xml_diff>
--- a/docs/content/multivariate_statistics/multivariate_statistics_lecture.pptx
+++ b/docs/content/multivariate_statistics/multivariate_statistics_lecture.pptx
@@ -21684,6 +21684,86 @@
                 </a:solidFill>
                 <a:latin typeface="Courier"/>
               </a:rPr>
+              <a:t>##          Df SumOfSqs      R2      F Pr(&gt;F)    </a:t>
+            </a:r>
+            <a:br/>
+            <a:r>
+              <a:rPr i="1">
+                <a:solidFill>
+                  <a:srgbClr val="5E5E5E"/>
+                </a:solidFill>
+                <a:latin typeface="Courier"/>
+              </a:rPr>
+              <a:t>## Model     1   32.602 0.10636 5.7128  0.001 ***</a:t>
+            </a:r>
+            <a:br/>
+            <a:r>
+              <a:rPr i="1">
+                <a:solidFill>
+                  <a:srgbClr val="5E5E5E"/>
+                </a:solidFill>
+                <a:latin typeface="Courier"/>
+              </a:rPr>
+              <a:t>## Residual 48  273.930 0.89364                  </a:t>
+            </a:r>
+            <a:br/>
+            <a:r>
+              <a:rPr i="1">
+                <a:solidFill>
+                  <a:srgbClr val="5E5E5E"/>
+                </a:solidFill>
+                <a:latin typeface="Courier"/>
+              </a:rPr>
+              <a:t>## Total    49  306.532 1.00000                  </a:t>
+            </a:r>
+            <a:br/>
+            <a:r>
+              <a:rPr i="1">
+                <a:solidFill>
+                  <a:srgbClr val="5E5E5E"/>
+                </a:solidFill>
+                <a:latin typeface="Courier"/>
+              </a:rPr>
+              <a:t>## ---</a:t>
+            </a:r>
+            <a:br/>
+            <a:r>
+              <a:rPr i="1">
+                <a:solidFill>
+                  <a:srgbClr val="5E5E5E"/>
+                </a:solidFill>
+                <a:latin typeface="Courier"/>
+              </a:rPr>
+              <a:t>## Signif. codes:  0 '***' 0.001 '**' 0.01 '*' 0.05 '.' 0.1 ' ' 1</a:t>
+            </a:r>
+            <a:br/>
+            <a:r>
+              <a:rPr i="1">
+                <a:solidFill>
+                  <a:srgbClr val="5E5E5E"/>
+                </a:solidFill>
+                <a:latin typeface="Courier"/>
+              </a:rPr>
+              <a:t>## </a:t>
+            </a:r>
+            <a:br/>
+            <a:r>
+              <a:rPr i="1">
+                <a:solidFill>
+                  <a:srgbClr val="5E5E5E"/>
+                </a:solidFill>
+                <a:latin typeface="Courier"/>
+              </a:rPr>
+              <a:t>## $TJH_vs_LEH</a:t>
+            </a:r>
+            <a:br/>
+            <a:r>
+              <a:rPr i="1">
+                <a:solidFill>
+                  <a:srgbClr val="5E5E5E"/>
+                </a:solidFill>
+                <a:latin typeface="Courier"/>
+              </a:rPr>
               <a:t>##          Df SumOfSqs      R2      F Pr(&gt;F)   </a:t>
             </a:r>
             <a:br/>
@@ -21694,7 +21774,7 @@
                 </a:solidFill>
                 <a:latin typeface="Courier"/>
               </a:rPr>
-              <a:t>## Model     1   32.602 0.10636 5.7128  0.002 **</a:t>
+              <a:t>## Model     1    47.72 0.10517 5.6414  0.003 **</a:t>
             </a:r>
             <a:br/>
             <a:r>
@@ -21704,7 +21784,7 @@
                 </a:solidFill>
                 <a:latin typeface="Courier"/>
               </a:rPr>
-              <a:t>## Residual 48  273.930 0.89364                 </a:t>
+              <a:t>## Residual 48   406.06 0.89483                 </a:t>
             </a:r>
             <a:br/>
             <a:r>
@@ -21714,7 +21794,7 @@
                 </a:solidFill>
                 <a:latin typeface="Courier"/>
               </a:rPr>
-              <a:t>## Total    49  306.532 1.00000                 </a:t>
+              <a:t>## Total    49   453.78 1.00000                 </a:t>
             </a:r>
             <a:br/>
             <a:r>
@@ -21754,7 +21834,7 @@
                 </a:solidFill>
                 <a:latin typeface="Courier"/>
               </a:rPr>
-              <a:t>## $TJH_vs_LEH</a:t>
+              <a:t>## $TJH_vs_HD</a:t>
             </a:r>
             <a:br/>
             <a:r>
@@ -21764,7 +21844,7 @@
                 </a:solidFill>
                 <a:latin typeface="Courier"/>
               </a:rPr>
-              <a:t>##          Df SumOfSqs      R2      F Pr(&gt;F)   </a:t>
+              <a:t>##          Df SumOfSqs      R2      F Pr(&gt;F)    </a:t>
             </a:r>
             <a:br/>
             <a:r>
@@ -21774,7 +21854,7 @@
                 </a:solidFill>
                 <a:latin typeface="Courier"/>
               </a:rPr>
-              <a:t>## Model     1    47.72 0.10517 5.6414  0.006 **</a:t>
+              <a:t>## Model     1   69.308 0.25135 11.751  0.001 ***</a:t>
             </a:r>
             <a:br/>
             <a:r>
@@ -21784,7 +21864,7 @@
                 </a:solidFill>
                 <a:latin typeface="Courier"/>
               </a:rPr>
-              <a:t>## Residual 48   406.06 0.89483                 </a:t>
+              <a:t>## Residual 35  206.432 0.74865                  </a:t>
             </a:r>
             <a:br/>
             <a:r>
@@ -21794,7 +21874,7 @@
                 </a:solidFill>
                 <a:latin typeface="Courier"/>
               </a:rPr>
-              <a:t>## Total    49   453.78 1.00000                 </a:t>
+              <a:t>## Total    36  275.740 1.00000                  </a:t>
             </a:r>
             <a:br/>
             <a:r>
@@ -21834,7 +21914,7 @@
                 </a:solidFill>
                 <a:latin typeface="Courier"/>
               </a:rPr>
-              <a:t>## $TJH_vs_HD</a:t>
+              <a:t>## $DG_vs_LEH</a:t>
             </a:r>
             <a:br/>
             <a:r>
@@ -21844,7 +21924,7 @@
                 </a:solidFill>
                 <a:latin typeface="Courier"/>
               </a:rPr>
-              <a:t>##          Df SumOfSqs      R2      F Pr(&gt;F)    </a:t>
+              <a:t>##          Df SumOfSqs      R2      F Pr(&gt;F)  </a:t>
             </a:r>
             <a:br/>
             <a:r>
@@ -21854,87 +21934,7 @@
                 </a:solidFill>
                 <a:latin typeface="Courier"/>
               </a:rPr>
-              <a:t>## Model     1   69.308 0.25135 11.751  0.001 ***</a:t>
-            </a:r>
-            <a:br/>
-            <a:r>
-              <a:rPr i="1">
-                <a:solidFill>
-                  <a:srgbClr val="5E5E5E"/>
-                </a:solidFill>
-                <a:latin typeface="Courier"/>
-              </a:rPr>
-              <a:t>## Residual 35  206.432 0.74865                  </a:t>
-            </a:r>
-            <a:br/>
-            <a:r>
-              <a:rPr i="1">
-                <a:solidFill>
-                  <a:srgbClr val="5E5E5E"/>
-                </a:solidFill>
-                <a:latin typeface="Courier"/>
-              </a:rPr>
-              <a:t>## Total    36  275.740 1.00000                  </a:t>
-            </a:r>
-            <a:br/>
-            <a:r>
-              <a:rPr i="1">
-                <a:solidFill>
-                  <a:srgbClr val="5E5E5E"/>
-                </a:solidFill>
-                <a:latin typeface="Courier"/>
-              </a:rPr>
-              <a:t>## ---</a:t>
-            </a:r>
-            <a:br/>
-            <a:r>
-              <a:rPr i="1">
-                <a:solidFill>
-                  <a:srgbClr val="5E5E5E"/>
-                </a:solidFill>
-                <a:latin typeface="Courier"/>
-              </a:rPr>
-              <a:t>## Signif. codes:  0 '***' 0.001 '**' 0.01 '*' 0.05 '.' 0.1 ' ' 1</a:t>
-            </a:r>
-            <a:br/>
-            <a:r>
-              <a:rPr i="1">
-                <a:solidFill>
-                  <a:srgbClr val="5E5E5E"/>
-                </a:solidFill>
-                <a:latin typeface="Courier"/>
-              </a:rPr>
-              <a:t>## </a:t>
-            </a:r>
-            <a:br/>
-            <a:r>
-              <a:rPr i="1">
-                <a:solidFill>
-                  <a:srgbClr val="5E5E5E"/>
-                </a:solidFill>
-                <a:latin typeface="Courier"/>
-              </a:rPr>
-              <a:t>## $DG_vs_LEH</a:t>
-            </a:r>
-            <a:br/>
-            <a:r>
-              <a:rPr i="1">
-                <a:solidFill>
-                  <a:srgbClr val="5E5E5E"/>
-                </a:solidFill>
-                <a:latin typeface="Courier"/>
-              </a:rPr>
-              <a:t>##          Df SumOfSqs      R2      F Pr(&gt;F)  </a:t>
-            </a:r>
-            <a:br/>
-            <a:r>
-              <a:rPr i="1">
-                <a:solidFill>
-                  <a:srgbClr val="5E5E5E"/>
-                </a:solidFill>
-                <a:latin typeface="Courier"/>
-              </a:rPr>
-              <a:t>## Model     1    26.24 0.06493 3.3333  0.027 *</a:t>
+              <a:t>## Model     1    26.24 0.06493 3.3333  0.021 *</a:t>
             </a:r>
             <a:br/>
             <a:r>
@@ -22605,7 +22605,7 @@
                 </a:solidFill>
                 <a:latin typeface="Courier"/>
               </a:rPr>
-              <a:t>## LEH 0.096 0.006 -    </a:t>
+              <a:t>## LEH 0.114 0.006 -    </a:t>
             </a:r>
             <a:br/>
             <a:r>
@@ -22615,7 +22615,7 @@
                 </a:solidFill>
                 <a:latin typeface="Courier"/>
               </a:rPr>
-              <a:t>## TJH 0.006 0.006 0.018</a:t>
+              <a:t>## TJH 0.012 0.006 0.018</a:t>
             </a:r>
             <a:br/>
             <a:r>

</xml_diff>

<commit_message>
starting to do the multiple regression
</commit_message>
<xml_diff>
--- a/docs/content/multivariate_statistics/multivariate_statistics_lecture.pptx
+++ b/docs/content/multivariate_statistics/multivariate_statistics_lecture.pptx
@@ -21684,6 +21684,86 @@
                 </a:solidFill>
                 <a:latin typeface="Courier"/>
               </a:rPr>
+              <a:t>##          Df SumOfSqs      R2      F Pr(&gt;F)    </a:t>
+            </a:r>
+            <a:br/>
+            <a:r>
+              <a:rPr i="1">
+                <a:solidFill>
+                  <a:srgbClr val="5E5E5E"/>
+                </a:solidFill>
+                <a:latin typeface="Courier"/>
+              </a:rPr>
+              <a:t>## Model     1   32.602 0.10636 5.7128  0.001 ***</a:t>
+            </a:r>
+            <a:br/>
+            <a:r>
+              <a:rPr i="1">
+                <a:solidFill>
+                  <a:srgbClr val="5E5E5E"/>
+                </a:solidFill>
+                <a:latin typeface="Courier"/>
+              </a:rPr>
+              <a:t>## Residual 48  273.930 0.89364                  </a:t>
+            </a:r>
+            <a:br/>
+            <a:r>
+              <a:rPr i="1">
+                <a:solidFill>
+                  <a:srgbClr val="5E5E5E"/>
+                </a:solidFill>
+                <a:latin typeface="Courier"/>
+              </a:rPr>
+              <a:t>## Total    49  306.532 1.00000                  </a:t>
+            </a:r>
+            <a:br/>
+            <a:r>
+              <a:rPr i="1">
+                <a:solidFill>
+                  <a:srgbClr val="5E5E5E"/>
+                </a:solidFill>
+                <a:latin typeface="Courier"/>
+              </a:rPr>
+              <a:t>## ---</a:t>
+            </a:r>
+            <a:br/>
+            <a:r>
+              <a:rPr i="1">
+                <a:solidFill>
+                  <a:srgbClr val="5E5E5E"/>
+                </a:solidFill>
+                <a:latin typeface="Courier"/>
+              </a:rPr>
+              <a:t>## Signif. codes:  0 '***' 0.001 '**' 0.01 '*' 0.05 '.' 0.1 ' ' 1</a:t>
+            </a:r>
+            <a:br/>
+            <a:r>
+              <a:rPr i="1">
+                <a:solidFill>
+                  <a:srgbClr val="5E5E5E"/>
+                </a:solidFill>
+                <a:latin typeface="Courier"/>
+              </a:rPr>
+              <a:t>## </a:t>
+            </a:r>
+            <a:br/>
+            <a:r>
+              <a:rPr i="1">
+                <a:solidFill>
+                  <a:srgbClr val="5E5E5E"/>
+                </a:solidFill>
+                <a:latin typeface="Courier"/>
+              </a:rPr>
+              <a:t>## $TJH_vs_LEH</a:t>
+            </a:r>
+            <a:br/>
+            <a:r>
+              <a:rPr i="1">
+                <a:solidFill>
+                  <a:srgbClr val="5E5E5E"/>
+                </a:solidFill>
+                <a:latin typeface="Courier"/>
+              </a:rPr>
               <a:t>##          Df SumOfSqs      R2      F Pr(&gt;F)   </a:t>
             </a:r>
             <a:br/>
@@ -21694,7 +21774,7 @@
                 </a:solidFill>
                 <a:latin typeface="Courier"/>
               </a:rPr>
-              <a:t>## Model     1   32.602 0.10636 5.7128  0.003 **</a:t>
+              <a:t>## Model     1    47.72 0.10517 5.6414  0.003 **</a:t>
             </a:r>
             <a:br/>
             <a:r>
@@ -21704,7 +21784,7 @@
                 </a:solidFill>
                 <a:latin typeface="Courier"/>
               </a:rPr>
-              <a:t>## Residual 48  273.930 0.89364                 </a:t>
+              <a:t>## Residual 48   406.06 0.89483                 </a:t>
             </a:r>
             <a:br/>
             <a:r>
@@ -21714,7 +21794,7 @@
                 </a:solidFill>
                 <a:latin typeface="Courier"/>
               </a:rPr>
-              <a:t>## Total    49  306.532 1.00000                 </a:t>
+              <a:t>## Total    49   453.78 1.00000                 </a:t>
             </a:r>
             <a:br/>
             <a:r>
@@ -21754,7 +21834,7 @@
                 </a:solidFill>
                 <a:latin typeface="Courier"/>
               </a:rPr>
-              <a:t>## $TJH_vs_LEH</a:t>
+              <a:t>## $TJH_vs_HD</a:t>
             </a:r>
             <a:br/>
             <a:r>
@@ -21764,7 +21844,7 @@
                 </a:solidFill>
                 <a:latin typeface="Courier"/>
               </a:rPr>
-              <a:t>##          Df SumOfSqs      R2      F Pr(&gt;F)   </a:t>
+              <a:t>##          Df SumOfSqs      R2      F Pr(&gt;F)    </a:t>
             </a:r>
             <a:br/>
             <a:r>
@@ -21774,7 +21854,7 @@
                 </a:solidFill>
                 <a:latin typeface="Courier"/>
               </a:rPr>
-              <a:t>## Model     1    47.72 0.10517 5.6414  0.002 **</a:t>
+              <a:t>## Model     1   69.308 0.25135 11.751  0.001 ***</a:t>
             </a:r>
             <a:br/>
             <a:r>
@@ -21784,7 +21864,7 @@
                 </a:solidFill>
                 <a:latin typeface="Courier"/>
               </a:rPr>
-              <a:t>## Residual 48   406.06 0.89483                 </a:t>
+              <a:t>## Residual 35  206.432 0.74865                  </a:t>
             </a:r>
             <a:br/>
             <a:r>
@@ -21794,7 +21874,7 @@
                 </a:solidFill>
                 <a:latin typeface="Courier"/>
               </a:rPr>
-              <a:t>## Total    49   453.78 1.00000                 </a:t>
+              <a:t>## Total    36  275.740 1.00000                  </a:t>
             </a:r>
             <a:br/>
             <a:r>
@@ -21834,7 +21914,7 @@
                 </a:solidFill>
                 <a:latin typeface="Courier"/>
               </a:rPr>
-              <a:t>## $TJH_vs_HD</a:t>
+              <a:t>## $DG_vs_LEH</a:t>
             </a:r>
             <a:br/>
             <a:r>
@@ -21844,7 +21924,7 @@
                 </a:solidFill>
                 <a:latin typeface="Courier"/>
               </a:rPr>
-              <a:t>##          Df SumOfSqs      R2      F Pr(&gt;F)    </a:t>
+              <a:t>##          Df SumOfSqs      R2      F Pr(&gt;F)  </a:t>
             </a:r>
             <a:br/>
             <a:r>
@@ -21854,87 +21934,7 @@
                 </a:solidFill>
                 <a:latin typeface="Courier"/>
               </a:rPr>
-              <a:t>## Model     1   69.308 0.25135 11.751  0.001 ***</a:t>
-            </a:r>
-            <a:br/>
-            <a:r>
-              <a:rPr i="1">
-                <a:solidFill>
-                  <a:srgbClr val="5E5E5E"/>
-                </a:solidFill>
-                <a:latin typeface="Courier"/>
-              </a:rPr>
-              <a:t>## Residual 35  206.432 0.74865                  </a:t>
-            </a:r>
-            <a:br/>
-            <a:r>
-              <a:rPr i="1">
-                <a:solidFill>
-                  <a:srgbClr val="5E5E5E"/>
-                </a:solidFill>
-                <a:latin typeface="Courier"/>
-              </a:rPr>
-              <a:t>## Total    36  275.740 1.00000                  </a:t>
-            </a:r>
-            <a:br/>
-            <a:r>
-              <a:rPr i="1">
-                <a:solidFill>
-                  <a:srgbClr val="5E5E5E"/>
-                </a:solidFill>
-                <a:latin typeface="Courier"/>
-              </a:rPr>
-              <a:t>## ---</a:t>
-            </a:r>
-            <a:br/>
-            <a:r>
-              <a:rPr i="1">
-                <a:solidFill>
-                  <a:srgbClr val="5E5E5E"/>
-                </a:solidFill>
-                <a:latin typeface="Courier"/>
-              </a:rPr>
-              <a:t>## Signif. codes:  0 '***' 0.001 '**' 0.01 '*' 0.05 '.' 0.1 ' ' 1</a:t>
-            </a:r>
-            <a:br/>
-            <a:r>
-              <a:rPr i="1">
-                <a:solidFill>
-                  <a:srgbClr val="5E5E5E"/>
-                </a:solidFill>
-                <a:latin typeface="Courier"/>
-              </a:rPr>
-              <a:t>## </a:t>
-            </a:r>
-            <a:br/>
-            <a:r>
-              <a:rPr i="1">
-                <a:solidFill>
-                  <a:srgbClr val="5E5E5E"/>
-                </a:solidFill>
-                <a:latin typeface="Courier"/>
-              </a:rPr>
-              <a:t>## $DG_vs_LEH</a:t>
-            </a:r>
-            <a:br/>
-            <a:r>
-              <a:rPr i="1">
-                <a:solidFill>
-                  <a:srgbClr val="5E5E5E"/>
-                </a:solidFill>
-                <a:latin typeface="Courier"/>
-              </a:rPr>
-              <a:t>##          Df SumOfSqs      R2      F Pr(&gt;F)  </a:t>
-            </a:r>
-            <a:br/>
-            <a:r>
-              <a:rPr i="1">
-                <a:solidFill>
-                  <a:srgbClr val="5E5E5E"/>
-                </a:solidFill>
-                <a:latin typeface="Courier"/>
-              </a:rPr>
-              <a:t>## Model     1    26.24 0.06493 3.3333  0.027 *</a:t>
+              <a:t>## Model     1    26.24 0.06493 3.3333  0.022 *</a:t>
             </a:r>
             <a:br/>
             <a:r>
@@ -22605,7 +22605,7 @@
                 </a:solidFill>
                 <a:latin typeface="Courier"/>
               </a:rPr>
-              <a:t>## LEH 0.102 0.006 -    </a:t>
+              <a:t>## LEH 0.132 0.006 -    </a:t>
             </a:r>
             <a:br/>
             <a:r>
@@ -22615,7 +22615,7 @@
                 </a:solidFill>
                 <a:latin typeface="Courier"/>
               </a:rPr>
-              <a:t>## TJH 0.006 0.006 0.006</a:t>
+              <a:t>## TJH 0.012 0.006 0.018</a:t>
             </a:r>
             <a:br/>
             <a:r>

</xml_diff>

<commit_message>
fixed fiddler crab photo again
</commit_message>
<xml_diff>
--- a/docs/content/multivariate_statistics/multivariate_statistics_lecture.pptx
+++ b/docs/content/multivariate_statistics/multivariate_statistics_lecture.pptx
@@ -21684,6 +21684,166 @@
                 </a:solidFill>
                 <a:latin typeface="Courier"/>
               </a:rPr>
+              <a:t>##          Df SumOfSqs      R2      F Pr(&gt;F)   </a:t>
+            </a:r>
+            <a:br/>
+            <a:r>
+              <a:rPr i="1">
+                <a:solidFill>
+                  <a:srgbClr val="5E5E5E"/>
+                </a:solidFill>
+                <a:latin typeface="Courier"/>
+              </a:rPr>
+              <a:t>## Model     1   32.602 0.10636 5.7128  0.005 **</a:t>
+            </a:r>
+            <a:br/>
+            <a:r>
+              <a:rPr i="1">
+                <a:solidFill>
+                  <a:srgbClr val="5E5E5E"/>
+                </a:solidFill>
+                <a:latin typeface="Courier"/>
+              </a:rPr>
+              <a:t>## Residual 48  273.930 0.89364                 </a:t>
+            </a:r>
+            <a:br/>
+            <a:r>
+              <a:rPr i="1">
+                <a:solidFill>
+                  <a:srgbClr val="5E5E5E"/>
+                </a:solidFill>
+                <a:latin typeface="Courier"/>
+              </a:rPr>
+              <a:t>## Total    49  306.532 1.00000                 </a:t>
+            </a:r>
+            <a:br/>
+            <a:r>
+              <a:rPr i="1">
+                <a:solidFill>
+                  <a:srgbClr val="5E5E5E"/>
+                </a:solidFill>
+                <a:latin typeface="Courier"/>
+              </a:rPr>
+              <a:t>## ---</a:t>
+            </a:r>
+            <a:br/>
+            <a:r>
+              <a:rPr i="1">
+                <a:solidFill>
+                  <a:srgbClr val="5E5E5E"/>
+                </a:solidFill>
+                <a:latin typeface="Courier"/>
+              </a:rPr>
+              <a:t>## Signif. codes:  0 '***' 0.001 '**' 0.01 '*' 0.05 '.' 0.1 ' ' 1</a:t>
+            </a:r>
+            <a:br/>
+            <a:r>
+              <a:rPr i="1">
+                <a:solidFill>
+                  <a:srgbClr val="5E5E5E"/>
+                </a:solidFill>
+                <a:latin typeface="Courier"/>
+              </a:rPr>
+              <a:t>## </a:t>
+            </a:r>
+            <a:br/>
+            <a:r>
+              <a:rPr i="1">
+                <a:solidFill>
+                  <a:srgbClr val="5E5E5E"/>
+                </a:solidFill>
+                <a:latin typeface="Courier"/>
+              </a:rPr>
+              <a:t>## $TJH_vs_LEH</a:t>
+            </a:r>
+            <a:br/>
+            <a:r>
+              <a:rPr i="1">
+                <a:solidFill>
+                  <a:srgbClr val="5E5E5E"/>
+                </a:solidFill>
+                <a:latin typeface="Courier"/>
+              </a:rPr>
+              <a:t>##          Df SumOfSqs      R2      F Pr(&gt;F)   </a:t>
+            </a:r>
+            <a:br/>
+            <a:r>
+              <a:rPr i="1">
+                <a:solidFill>
+                  <a:srgbClr val="5E5E5E"/>
+                </a:solidFill>
+                <a:latin typeface="Courier"/>
+              </a:rPr>
+              <a:t>## Model     1    47.72 0.10517 5.6414  0.003 **</a:t>
+            </a:r>
+            <a:br/>
+            <a:r>
+              <a:rPr i="1">
+                <a:solidFill>
+                  <a:srgbClr val="5E5E5E"/>
+                </a:solidFill>
+                <a:latin typeface="Courier"/>
+              </a:rPr>
+              <a:t>## Residual 48   406.06 0.89483                 </a:t>
+            </a:r>
+            <a:br/>
+            <a:r>
+              <a:rPr i="1">
+                <a:solidFill>
+                  <a:srgbClr val="5E5E5E"/>
+                </a:solidFill>
+                <a:latin typeface="Courier"/>
+              </a:rPr>
+              <a:t>## Total    49   453.78 1.00000                 </a:t>
+            </a:r>
+            <a:br/>
+            <a:r>
+              <a:rPr i="1">
+                <a:solidFill>
+                  <a:srgbClr val="5E5E5E"/>
+                </a:solidFill>
+                <a:latin typeface="Courier"/>
+              </a:rPr>
+              <a:t>## ---</a:t>
+            </a:r>
+            <a:br/>
+            <a:r>
+              <a:rPr i="1">
+                <a:solidFill>
+                  <a:srgbClr val="5E5E5E"/>
+                </a:solidFill>
+                <a:latin typeface="Courier"/>
+              </a:rPr>
+              <a:t>## Signif. codes:  0 '***' 0.001 '**' 0.01 '*' 0.05 '.' 0.1 ' ' 1</a:t>
+            </a:r>
+            <a:br/>
+            <a:r>
+              <a:rPr i="1">
+                <a:solidFill>
+                  <a:srgbClr val="5E5E5E"/>
+                </a:solidFill>
+                <a:latin typeface="Courier"/>
+              </a:rPr>
+              <a:t>## </a:t>
+            </a:r>
+            <a:br/>
+            <a:r>
+              <a:rPr i="1">
+                <a:solidFill>
+                  <a:srgbClr val="5E5E5E"/>
+                </a:solidFill>
+                <a:latin typeface="Courier"/>
+              </a:rPr>
+              <a:t>## $TJH_vs_HD</a:t>
+            </a:r>
+            <a:br/>
+            <a:r>
+              <a:rPr i="1">
+                <a:solidFill>
+                  <a:srgbClr val="5E5E5E"/>
+                </a:solidFill>
+                <a:latin typeface="Courier"/>
+              </a:rPr>
               <a:t>##          Df SumOfSqs      R2      F Pr(&gt;F)    </a:t>
             </a:r>
             <a:br/>
@@ -21694,7 +21854,7 @@
                 </a:solidFill>
                 <a:latin typeface="Courier"/>
               </a:rPr>
-              <a:t>## Model     1   32.602 0.10636 5.7128  0.001 ***</a:t>
+              <a:t>## Model     1   69.308 0.25135 11.751  0.001 ***</a:t>
             </a:r>
             <a:br/>
             <a:r>
@@ -21704,7 +21864,7 @@
                 </a:solidFill>
                 <a:latin typeface="Courier"/>
               </a:rPr>
-              <a:t>## Residual 48  273.930 0.89364                  </a:t>
+              <a:t>## Residual 35  206.432 0.74865                  </a:t>
             </a:r>
             <a:br/>
             <a:r>
@@ -21714,7 +21874,7 @@
                 </a:solidFill>
                 <a:latin typeface="Courier"/>
               </a:rPr>
-              <a:t>## Total    49  306.532 1.00000                  </a:t>
+              <a:t>## Total    36  275.740 1.00000                  </a:t>
             </a:r>
             <a:br/>
             <a:r>
@@ -21754,7 +21914,7 @@
                 </a:solidFill>
                 <a:latin typeface="Courier"/>
               </a:rPr>
-              <a:t>## $TJH_vs_LEH</a:t>
+              <a:t>## $DG_vs_LEH</a:t>
             </a:r>
             <a:br/>
             <a:r>
@@ -21764,7 +21924,7 @@
                 </a:solidFill>
                 <a:latin typeface="Courier"/>
               </a:rPr>
-              <a:t>##          Df SumOfSqs      R2      F Pr(&gt;F)   </a:t>
+              <a:t>##          Df SumOfSqs      R2      F Pr(&gt;F)  </a:t>
             </a:r>
             <a:br/>
             <a:r>
@@ -21774,167 +21934,7 @@
                 </a:solidFill>
                 <a:latin typeface="Courier"/>
               </a:rPr>
-              <a:t>## Model     1    47.72 0.10517 5.6414  0.006 **</a:t>
-            </a:r>
-            <a:br/>
-            <a:r>
-              <a:rPr i="1">
-                <a:solidFill>
-                  <a:srgbClr val="5E5E5E"/>
-                </a:solidFill>
-                <a:latin typeface="Courier"/>
-              </a:rPr>
-              <a:t>## Residual 48   406.06 0.89483                 </a:t>
-            </a:r>
-            <a:br/>
-            <a:r>
-              <a:rPr i="1">
-                <a:solidFill>
-                  <a:srgbClr val="5E5E5E"/>
-                </a:solidFill>
-                <a:latin typeface="Courier"/>
-              </a:rPr>
-              <a:t>## Total    49   453.78 1.00000                 </a:t>
-            </a:r>
-            <a:br/>
-            <a:r>
-              <a:rPr i="1">
-                <a:solidFill>
-                  <a:srgbClr val="5E5E5E"/>
-                </a:solidFill>
-                <a:latin typeface="Courier"/>
-              </a:rPr>
-              <a:t>## ---</a:t>
-            </a:r>
-            <a:br/>
-            <a:r>
-              <a:rPr i="1">
-                <a:solidFill>
-                  <a:srgbClr val="5E5E5E"/>
-                </a:solidFill>
-                <a:latin typeface="Courier"/>
-              </a:rPr>
-              <a:t>## Signif. codes:  0 '***' 0.001 '**' 0.01 '*' 0.05 '.' 0.1 ' ' 1</a:t>
-            </a:r>
-            <a:br/>
-            <a:r>
-              <a:rPr i="1">
-                <a:solidFill>
-                  <a:srgbClr val="5E5E5E"/>
-                </a:solidFill>
-                <a:latin typeface="Courier"/>
-              </a:rPr>
-              <a:t>## </a:t>
-            </a:r>
-            <a:br/>
-            <a:r>
-              <a:rPr i="1">
-                <a:solidFill>
-                  <a:srgbClr val="5E5E5E"/>
-                </a:solidFill>
-                <a:latin typeface="Courier"/>
-              </a:rPr>
-              <a:t>## $TJH_vs_HD</a:t>
-            </a:r>
-            <a:br/>
-            <a:r>
-              <a:rPr i="1">
-                <a:solidFill>
-                  <a:srgbClr val="5E5E5E"/>
-                </a:solidFill>
-                <a:latin typeface="Courier"/>
-              </a:rPr>
-              <a:t>##          Df SumOfSqs      R2      F Pr(&gt;F)    </a:t>
-            </a:r>
-            <a:br/>
-            <a:r>
-              <a:rPr i="1">
-                <a:solidFill>
-                  <a:srgbClr val="5E5E5E"/>
-                </a:solidFill>
-                <a:latin typeface="Courier"/>
-              </a:rPr>
-              <a:t>## Model     1   69.308 0.25135 11.751  0.001 ***</a:t>
-            </a:r>
-            <a:br/>
-            <a:r>
-              <a:rPr i="1">
-                <a:solidFill>
-                  <a:srgbClr val="5E5E5E"/>
-                </a:solidFill>
-                <a:latin typeface="Courier"/>
-              </a:rPr>
-              <a:t>## Residual 35  206.432 0.74865                  </a:t>
-            </a:r>
-            <a:br/>
-            <a:r>
-              <a:rPr i="1">
-                <a:solidFill>
-                  <a:srgbClr val="5E5E5E"/>
-                </a:solidFill>
-                <a:latin typeface="Courier"/>
-              </a:rPr>
-              <a:t>## Total    36  275.740 1.00000                  </a:t>
-            </a:r>
-            <a:br/>
-            <a:r>
-              <a:rPr i="1">
-                <a:solidFill>
-                  <a:srgbClr val="5E5E5E"/>
-                </a:solidFill>
-                <a:latin typeface="Courier"/>
-              </a:rPr>
-              <a:t>## ---</a:t>
-            </a:r>
-            <a:br/>
-            <a:r>
-              <a:rPr i="1">
-                <a:solidFill>
-                  <a:srgbClr val="5E5E5E"/>
-                </a:solidFill>
-                <a:latin typeface="Courier"/>
-              </a:rPr>
-              <a:t>## Signif. codes:  0 '***' 0.001 '**' 0.01 '*' 0.05 '.' 0.1 ' ' 1</a:t>
-            </a:r>
-            <a:br/>
-            <a:r>
-              <a:rPr i="1">
-                <a:solidFill>
-                  <a:srgbClr val="5E5E5E"/>
-                </a:solidFill>
-                <a:latin typeface="Courier"/>
-              </a:rPr>
-              <a:t>## </a:t>
-            </a:r>
-            <a:br/>
-            <a:r>
-              <a:rPr i="1">
-                <a:solidFill>
-                  <a:srgbClr val="5E5E5E"/>
-                </a:solidFill>
-                <a:latin typeface="Courier"/>
-              </a:rPr>
-              <a:t>## $DG_vs_LEH</a:t>
-            </a:r>
-            <a:br/>
-            <a:r>
-              <a:rPr i="1">
-                <a:solidFill>
-                  <a:srgbClr val="5E5E5E"/>
-                </a:solidFill>
-                <a:latin typeface="Courier"/>
-              </a:rPr>
-              <a:t>##          Df SumOfSqs      R2      F Pr(&gt;F)  </a:t>
-            </a:r>
-            <a:br/>
-            <a:r>
-              <a:rPr i="1">
-                <a:solidFill>
-                  <a:srgbClr val="5E5E5E"/>
-                </a:solidFill>
-                <a:latin typeface="Courier"/>
-              </a:rPr>
-              <a:t>## Model     1    26.24 0.06493 3.3333  0.019 *</a:t>
+              <a:t>## Model     1    26.24 0.06493 3.3333  0.017 *</a:t>
             </a:r>
             <a:br/>
             <a:r>
@@ -22605,7 +22605,7 @@
                 </a:solidFill>
                 <a:latin typeface="Courier"/>
               </a:rPr>
-              <a:t>## LEH 0.090 0.006 -    </a:t>
+              <a:t>## LEH 0.120 0.006 -    </a:t>
             </a:r>
             <a:br/>
             <a:r>
@@ -22615,7 +22615,7 @@
                 </a:solidFill>
                 <a:latin typeface="Courier"/>
               </a:rPr>
-              <a:t>## TJH 0.018 0.006 0.018</a:t>
+              <a:t>## TJH 0.018 0.006 0.012</a:t>
             </a:r>
             <a:br/>
             <a:r>

</xml_diff>

<commit_message>
fixed summary vs anova
</commit_message>
<xml_diff>
--- a/docs/content/multivariate_statistics/multivariate_statistics_lecture.pptx
+++ b/docs/content/multivariate_statistics/multivariate_statistics_lecture.pptx
@@ -21684,6 +21684,86 @@
                 </a:solidFill>
                 <a:latin typeface="Courier"/>
               </a:rPr>
+              <a:t>##          Df SumOfSqs      R2      F Pr(&gt;F)    </a:t>
+            </a:r>
+            <a:br/>
+            <a:r>
+              <a:rPr i="1">
+                <a:solidFill>
+                  <a:srgbClr val="5E5E5E"/>
+                </a:solidFill>
+                <a:latin typeface="Courier"/>
+              </a:rPr>
+              <a:t>## Model     1   32.602 0.10636 5.7128  0.001 ***</a:t>
+            </a:r>
+            <a:br/>
+            <a:r>
+              <a:rPr i="1">
+                <a:solidFill>
+                  <a:srgbClr val="5E5E5E"/>
+                </a:solidFill>
+                <a:latin typeface="Courier"/>
+              </a:rPr>
+              <a:t>## Residual 48  273.930 0.89364                  </a:t>
+            </a:r>
+            <a:br/>
+            <a:r>
+              <a:rPr i="1">
+                <a:solidFill>
+                  <a:srgbClr val="5E5E5E"/>
+                </a:solidFill>
+                <a:latin typeface="Courier"/>
+              </a:rPr>
+              <a:t>## Total    49  306.532 1.00000                  </a:t>
+            </a:r>
+            <a:br/>
+            <a:r>
+              <a:rPr i="1">
+                <a:solidFill>
+                  <a:srgbClr val="5E5E5E"/>
+                </a:solidFill>
+                <a:latin typeface="Courier"/>
+              </a:rPr>
+              <a:t>## ---</a:t>
+            </a:r>
+            <a:br/>
+            <a:r>
+              <a:rPr i="1">
+                <a:solidFill>
+                  <a:srgbClr val="5E5E5E"/>
+                </a:solidFill>
+                <a:latin typeface="Courier"/>
+              </a:rPr>
+              <a:t>## Signif. codes:  0 '***' 0.001 '**' 0.01 '*' 0.05 '.' 0.1 ' ' 1</a:t>
+            </a:r>
+            <a:br/>
+            <a:r>
+              <a:rPr i="1">
+                <a:solidFill>
+                  <a:srgbClr val="5E5E5E"/>
+                </a:solidFill>
+                <a:latin typeface="Courier"/>
+              </a:rPr>
+              <a:t>## </a:t>
+            </a:r>
+            <a:br/>
+            <a:r>
+              <a:rPr i="1">
+                <a:solidFill>
+                  <a:srgbClr val="5E5E5E"/>
+                </a:solidFill>
+                <a:latin typeface="Courier"/>
+              </a:rPr>
+              <a:t>## $TJH_vs_LEH</a:t>
+            </a:r>
+            <a:br/>
+            <a:r>
+              <a:rPr i="1">
+                <a:solidFill>
+                  <a:srgbClr val="5E5E5E"/>
+                </a:solidFill>
+                <a:latin typeface="Courier"/>
+              </a:rPr>
               <a:t>##          Df SumOfSqs      R2      F Pr(&gt;F)   </a:t>
             </a:r>
             <a:br/>
@@ -21694,7 +21774,7 @@
                 </a:solidFill>
                 <a:latin typeface="Courier"/>
               </a:rPr>
-              <a:t>## Model     1   32.602 0.10636 5.7128  0.005 **</a:t>
+              <a:t>## Model     1    47.72 0.10517 5.6414  0.002 **</a:t>
             </a:r>
             <a:br/>
             <a:r>
@@ -21704,7 +21784,7 @@
                 </a:solidFill>
                 <a:latin typeface="Courier"/>
               </a:rPr>
-              <a:t>## Residual 48  273.930 0.89364                 </a:t>
+              <a:t>## Residual 48   406.06 0.89483                 </a:t>
             </a:r>
             <a:br/>
             <a:r>
@@ -21714,7 +21794,7 @@
                 </a:solidFill>
                 <a:latin typeface="Courier"/>
               </a:rPr>
-              <a:t>## Total    49  306.532 1.00000                 </a:t>
+              <a:t>## Total    49   453.78 1.00000                 </a:t>
             </a:r>
             <a:br/>
             <a:r>
@@ -21754,7 +21834,7 @@
                 </a:solidFill>
                 <a:latin typeface="Courier"/>
               </a:rPr>
-              <a:t>## $TJH_vs_LEH</a:t>
+              <a:t>## $TJH_vs_HD</a:t>
             </a:r>
             <a:br/>
             <a:r>
@@ -21764,7 +21844,7 @@
                 </a:solidFill>
                 <a:latin typeface="Courier"/>
               </a:rPr>
-              <a:t>##          Df SumOfSqs      R2      F Pr(&gt;F)   </a:t>
+              <a:t>##          Df SumOfSqs      R2      F Pr(&gt;F)    </a:t>
             </a:r>
             <a:br/>
             <a:r>
@@ -21774,7 +21854,7 @@
                 </a:solidFill>
                 <a:latin typeface="Courier"/>
               </a:rPr>
-              <a:t>## Model     1    47.72 0.10517 5.6414  0.003 **</a:t>
+              <a:t>## Model     1   69.308 0.25135 11.751  0.001 ***</a:t>
             </a:r>
             <a:br/>
             <a:r>
@@ -21784,7 +21864,7 @@
                 </a:solidFill>
                 <a:latin typeface="Courier"/>
               </a:rPr>
-              <a:t>## Residual 48   406.06 0.89483                 </a:t>
+              <a:t>## Residual 35  206.432 0.74865                  </a:t>
             </a:r>
             <a:br/>
             <a:r>
@@ -21794,7 +21874,7 @@
                 </a:solidFill>
                 <a:latin typeface="Courier"/>
               </a:rPr>
-              <a:t>## Total    49   453.78 1.00000                 </a:t>
+              <a:t>## Total    36  275.740 1.00000                  </a:t>
             </a:r>
             <a:br/>
             <a:r>
@@ -21834,7 +21914,7 @@
                 </a:solidFill>
                 <a:latin typeface="Courier"/>
               </a:rPr>
-              <a:t>## $TJH_vs_HD</a:t>
+              <a:t>## $DG_vs_LEH</a:t>
             </a:r>
             <a:br/>
             <a:r>
@@ -21844,7 +21924,7 @@
                 </a:solidFill>
                 <a:latin typeface="Courier"/>
               </a:rPr>
-              <a:t>##          Df SumOfSqs      R2      F Pr(&gt;F)    </a:t>
+              <a:t>##          Df SumOfSqs      R2      F Pr(&gt;F)  </a:t>
             </a:r>
             <a:br/>
             <a:r>
@@ -21854,87 +21934,7 @@
                 </a:solidFill>
                 <a:latin typeface="Courier"/>
               </a:rPr>
-              <a:t>## Model     1   69.308 0.25135 11.751  0.001 ***</a:t>
-            </a:r>
-            <a:br/>
-            <a:r>
-              <a:rPr i="1">
-                <a:solidFill>
-                  <a:srgbClr val="5E5E5E"/>
-                </a:solidFill>
-                <a:latin typeface="Courier"/>
-              </a:rPr>
-              <a:t>## Residual 35  206.432 0.74865                  </a:t>
-            </a:r>
-            <a:br/>
-            <a:r>
-              <a:rPr i="1">
-                <a:solidFill>
-                  <a:srgbClr val="5E5E5E"/>
-                </a:solidFill>
-                <a:latin typeface="Courier"/>
-              </a:rPr>
-              <a:t>## Total    36  275.740 1.00000                  </a:t>
-            </a:r>
-            <a:br/>
-            <a:r>
-              <a:rPr i="1">
-                <a:solidFill>
-                  <a:srgbClr val="5E5E5E"/>
-                </a:solidFill>
-                <a:latin typeface="Courier"/>
-              </a:rPr>
-              <a:t>## ---</a:t>
-            </a:r>
-            <a:br/>
-            <a:r>
-              <a:rPr i="1">
-                <a:solidFill>
-                  <a:srgbClr val="5E5E5E"/>
-                </a:solidFill>
-                <a:latin typeface="Courier"/>
-              </a:rPr>
-              <a:t>## Signif. codes:  0 '***' 0.001 '**' 0.01 '*' 0.05 '.' 0.1 ' ' 1</a:t>
-            </a:r>
-            <a:br/>
-            <a:r>
-              <a:rPr i="1">
-                <a:solidFill>
-                  <a:srgbClr val="5E5E5E"/>
-                </a:solidFill>
-                <a:latin typeface="Courier"/>
-              </a:rPr>
-              <a:t>## </a:t>
-            </a:r>
-            <a:br/>
-            <a:r>
-              <a:rPr i="1">
-                <a:solidFill>
-                  <a:srgbClr val="5E5E5E"/>
-                </a:solidFill>
-                <a:latin typeface="Courier"/>
-              </a:rPr>
-              <a:t>## $DG_vs_LEH</a:t>
-            </a:r>
-            <a:br/>
-            <a:r>
-              <a:rPr i="1">
-                <a:solidFill>
-                  <a:srgbClr val="5E5E5E"/>
-                </a:solidFill>
-                <a:latin typeface="Courier"/>
-              </a:rPr>
-              <a:t>##          Df SumOfSqs      R2      F Pr(&gt;F)  </a:t>
-            </a:r>
-            <a:br/>
-            <a:r>
-              <a:rPr i="1">
-                <a:solidFill>
-                  <a:srgbClr val="5E5E5E"/>
-                </a:solidFill>
-                <a:latin typeface="Courier"/>
-              </a:rPr>
-              <a:t>## Model     1    26.24 0.06493 3.3333  0.017 *</a:t>
+              <a:t>## Model     1    26.24 0.06493 3.3333  0.013 *</a:t>
             </a:r>
             <a:br/>
             <a:r>
@@ -22615,7 +22615,7 @@
                 </a:solidFill>
                 <a:latin typeface="Courier"/>
               </a:rPr>
-              <a:t>## TJH 0.018 0.006 0.012</a:t>
+              <a:t>## TJH 0.012 0.006 0.012</a:t>
             </a:r>
             <a:br/>
             <a:r>

</xml_diff>